<commit_message>
Match trust tree to the supplied dense twisting silhouette
</commit_message>
<xml_diff>
--- a/downloads/pravo_na_pravdu.pptx
+++ b/downloads/pravo_na_pravdu.pptx
@@ -507,7 +507,7 @@
           <a:lstStyle/>
           <a:p>
             <a:r>
-              <a:t>EVOLET. Демонстрационные итоги: цифры вымышлены. Статичный запасной вариант. Анимация и музыка доступны в index.html и MP4.</a:t>
+              <a:t>EVOLET. Демонстрационные итоги: цифры вымышлены. Статичный запасной вариант. Анимация дерева и музыка доступны в index.html и MP4.</a:t>
             </a:r>
           </a:p>
         </p:txBody>
@@ -577,7 +577,7 @@
           <a:lstStyle/>
           <a:p>
             <a:r>
-              <a:t>EVOLET. Демонстрационные итоги: цифры вымышлены. Статичный запасной вариант. Анимация и музыка доступны в index.html и MP4.</a:t>
+              <a:t>EVOLET. Демонстрационные итоги: цифры вымышлены. Статичный запасной вариант. Анимация дерева и музыка доступны в index.html и MP4.</a:t>
             </a:r>
           </a:p>
         </p:txBody>
@@ -647,7 +647,7 @@
           <a:lstStyle/>
           <a:p>
             <a:r>
-              <a:t>EVOLET. Демонстрационные итоги: цифры вымышлены. Статичный запасной вариант. Анимация и музыка доступны в index.html и MP4.</a:t>
+              <a:t>EVOLET. Демонстрационные итоги: цифры вымышлены. Статичный запасной вариант. Анимация дерева и музыка доступны в index.html и MP4.</a:t>
             </a:r>
           </a:p>
         </p:txBody>
@@ -717,7 +717,7 @@
           <a:lstStyle/>
           <a:p>
             <a:r>
-              <a:t>EVOLET. Демонстрационные итоги: цифры вымышлены. Статичный запасной вариант. Анимация и музыка доступны в index.html и MP4.</a:t>
+              <a:t>EVOLET. Демонстрационные итоги: цифры вымышлены. Статичный запасной вариант. Анимация дерева и музыка доступны в index.html и MP4.</a:t>
             </a:r>
           </a:p>
         </p:txBody>
@@ -787,7 +787,7 @@
           <a:lstStyle/>
           <a:p>
             <a:r>
-              <a:t>EVOLET. Демонстрационные итоги: цифры вымышлены. Статичный запасной вариант. Анимация и музыка доступны в index.html и MP4.</a:t>
+              <a:t>EVOLET. Демонстрационные итоги: цифры вымышлены. Статичный запасной вариант. Анимация дерева и музыка доступны в index.html и MP4.</a:t>
             </a:r>
           </a:p>
         </p:txBody>
@@ -857,7 +857,7 @@
           <a:lstStyle/>
           <a:p>
             <a:r>
-              <a:t>EVOLET. Демонстрационные итоги: цифры вымышлены. Статичный запасной вариант. Анимация и музыка доступны в index.html и MP4.</a:t>
+              <a:t>EVOLET. Демонстрационные итоги: цифры вымышлены. Статичный запасной вариант. Анимация дерева и музыка доступны в index.html и MP4.</a:t>
             </a:r>
           </a:p>
         </p:txBody>

</xml_diff>

<commit_message>
Grow tree continuously from emblem lines and fix replay and pause timing
</commit_message>
<xml_diff>
--- a/downloads/pravo_na_pravdu.pptx
+++ b/downloads/pravo_na_pravdu.pptx
@@ -507,7 +507,7 @@
           <a:lstStyle/>
           <a:p>
             <a:r>
-              <a:t>EVOLET. Демонстрационные итоги: цифры вымышлены. Статичный запасной вариант. Анимация дерева и музыка доступны в index.html и MP4.</a:t>
+              <a:t>EVOLET. Демонстрационные итоги. Статичный запасной вариант. Непрерывный рост из линий эмблемы доступен в HTML и MP4.</a:t>
             </a:r>
           </a:p>
         </p:txBody>
@@ -577,7 +577,7 @@
           <a:lstStyle/>
           <a:p>
             <a:r>
-              <a:t>EVOLET. Демонстрационные итоги: цифры вымышлены. Статичный запасной вариант. Анимация дерева и музыка доступны в index.html и MP4.</a:t>
+              <a:t>EVOLET. Демонстрационные итоги. Статичный запасной вариант. Непрерывный рост из линий эмблемы доступен в HTML и MP4.</a:t>
             </a:r>
           </a:p>
         </p:txBody>
@@ -647,7 +647,7 @@
           <a:lstStyle/>
           <a:p>
             <a:r>
-              <a:t>EVOLET. Демонстрационные итоги: цифры вымышлены. Статичный запасной вариант. Анимация дерева и музыка доступны в index.html и MP4.</a:t>
+              <a:t>EVOLET. Демонстрационные итоги. Статичный запасной вариант. Непрерывный рост из линий эмблемы доступен в HTML и MP4.</a:t>
             </a:r>
           </a:p>
         </p:txBody>
@@ -717,7 +717,7 @@
           <a:lstStyle/>
           <a:p>
             <a:r>
-              <a:t>EVOLET. Демонстрационные итоги: цифры вымышлены. Статичный запасной вариант. Анимация дерева и музыка доступны в index.html и MP4.</a:t>
+              <a:t>EVOLET. Демонстрационные итоги. Статичный запасной вариант. Непрерывный рост из линий эмблемы доступен в HTML и MP4.</a:t>
             </a:r>
           </a:p>
         </p:txBody>
@@ -787,7 +787,7 @@
           <a:lstStyle/>
           <a:p>
             <a:r>
-              <a:t>EVOLET. Демонстрационные итоги: цифры вымышлены. Статичный запасной вариант. Анимация дерева и музыка доступны в index.html и MP4.</a:t>
+              <a:t>EVOLET. Демонстрационные итоги. Статичный запасной вариант. Непрерывный рост из линий эмблемы доступен в HTML и MP4.</a:t>
             </a:r>
           </a:p>
         </p:txBody>
@@ -857,7 +857,7 @@
           <a:lstStyle/>
           <a:p>
             <a:r>
-              <a:t>EVOLET. Демонстрационные итоги: цифры вымышлены. Статичный запасной вариант. Анимация дерева и музыка доступны в index.html и MP4.</a:t>
+              <a:t>EVOLET. Демонстрационные итоги. Статичный запасной вариант. Непрерывный рост из линий эмблемы доступен в HTML и MP4.</a:t>
             </a:r>
           </a:p>
         </p:txBody>

</xml_diff>

<commit_message>
Build tree directly from logo strokes as connected vector paths
</commit_message>
<xml_diff>
--- a/downloads/pravo_na_pravdu.pptx
+++ b/downloads/pravo_na_pravdu.pptx
@@ -507,7 +507,7 @@
           <a:lstStyle/>
           <a:p>
             <a:r>
-              <a:t>EVOLET. Демонстрационные итоги. Статичный запасной вариант. Непрерывный рост из линий эмблемы доступен в HTML и MP4.</a:t>
+              <a:t>Все показатели — демонстрационные. Реальные результаты ещё не добавлены. Анимация и музыка доступны в index.html и MP4.</a:t>
             </a:r>
           </a:p>
         </p:txBody>
@@ -577,7 +577,7 @@
           <a:lstStyle/>
           <a:p>
             <a:r>
-              <a:t>EVOLET. Демонстрационные итоги. Статичный запасной вариант. Непрерывный рост из линий эмблемы доступен в HTML и MP4.</a:t>
+              <a:t>Все показатели — демонстрационные. Реальные результаты ещё не добавлены. Анимация и музыка доступны в index.html и MP4.</a:t>
             </a:r>
           </a:p>
         </p:txBody>
@@ -647,7 +647,7 @@
           <a:lstStyle/>
           <a:p>
             <a:r>
-              <a:t>EVOLET. Демонстрационные итоги. Статичный запасной вариант. Непрерывный рост из линий эмблемы доступен в HTML и MP4.</a:t>
+              <a:t>Все показатели — демонстрационные. Реальные результаты ещё не добавлены. Анимация и музыка доступны в index.html и MP4.</a:t>
             </a:r>
           </a:p>
         </p:txBody>
@@ -717,7 +717,7 @@
           <a:lstStyle/>
           <a:p>
             <a:r>
-              <a:t>EVOLET. Демонстрационные итоги. Статичный запасной вариант. Непрерывный рост из линий эмблемы доступен в HTML и MP4.</a:t>
+              <a:t>Все показатели — демонстрационные. Реальные результаты ещё не добавлены. Анимация и музыка доступны в index.html и MP4.</a:t>
             </a:r>
           </a:p>
         </p:txBody>
@@ -787,7 +787,7 @@
           <a:lstStyle/>
           <a:p>
             <a:r>
-              <a:t>EVOLET. Демонстрационные итоги. Статичный запасной вариант. Непрерывный рост из линий эмблемы доступен в HTML и MP4.</a:t>
+              <a:t>Все показатели — демонстрационные. Реальные результаты ещё не добавлены. Анимация и музыка доступны в index.html и MP4.</a:t>
             </a:r>
           </a:p>
         </p:txBody>
@@ -857,7 +857,7 @@
           <a:lstStyle/>
           <a:p>
             <a:r>
-              <a:t>EVOLET. Демонстрационные итоги. Статичный запасной вариант. Непрерывный рост из линий эмблемы доступен в HTML и MP4.</a:t>
+              <a:t>Все показатели — демонстрационные. Реальные результаты ещё не добавлены. Анимация и музыка доступны в index.html и MP4.</a:t>
             </a:r>
           </a:p>
         </p:txBody>

</xml_diff>

<commit_message>
Present five experiment conclusions with thematic animations
</commit_message>
<xml_diff>
--- a/downloads/pravo_na_pravdu.pptx
+++ b/downloads/pravo_na_pravdu.pptx
@@ -10,7 +10,6 @@
     <p:sldId id="258" r:id="rId10"/>
     <p:sldId id="259" r:id="rId11"/>
     <p:sldId id="260" r:id="rId12"/>
-    <p:sldId id="261" r:id="rId13"/>
   </p:sldIdLst>
   <p:sldSz cx="12191695" cy="8615510" type="screen4x3"/>
   <p:notesSz cx="6858000" cy="9144000"/>
@@ -507,7 +506,31 @@
           <a:lstStyle/>
           <a:p>
             <a:r>
-              <a:t>Все показатели — демонстрационные. Реальные результаты ещё не добавлены. Анимация и музыка доступны в index.html и MP4.</a:t>
+              <a:t>Мы ожидали, что наше дерево доверия получится пышным. Но некоторые ветви так и остались пустыми.</a:t>
+            </a:r>
+          </a:p>
+          <a:p/>
+          <a:p>
+            <a:r>
+              <a:t>[Пауза. Дать коллегам рассмотреть дерево.]</a:t>
+            </a:r>
+          </a:p>
+          <a:p/>
+          <a:p>
+            <a:r>
+              <a:t>Для нас это стало одним из самых важных наблюдений. Доверие не возникает само по себе, даже если для него придумана хорошая идея и создана возможность проявить себя.</a:t>
+            </a:r>
+          </a:p>
+          <a:p/>
+          <a:p>
+            <a:r>
+              <a:t>Ему нужны участие, открытость и шаг навстречу от каждого. Одного желания организаторов здесь недостаточно.</a:t>
+            </a:r>
+          </a:p>
+          <a:p/>
+          <a:p>
+            <a:r>
+              <a:t>Мы не хотим прятать пустые ветви: они тоже часть нашего результата. Они напоминают, что отношения требуют общего участия. Доверие невозможно построить в одиночку.</a:t>
             </a:r>
           </a:p>
         </p:txBody>
@@ -577,7 +600,25 @@
           <a:lstStyle/>
           <a:p>
             <a:r>
-              <a:t>Все показатели — демонстрационные. Реальные результаты ещё не добавлены. Анимация и музыка доступны в index.html и MP4.</a:t>
+              <a:t>Во втором эксперименте мы не изменили ни одного ответа. Мы изменили только вопросы. И те же самые слова приобрели совершенно другой смысл.</a:t>
+            </a:r>
+          </a:p>
+          <a:p/>
+          <a:p>
+            <a:r>
+              <a:t>Нам было важно обратить внимание на то, как доверие влияет на восприятие информации. Мы слышим ответ, но не всегда можем проверить весь контекст, в котором он прозвучал.</a:t>
+            </a:r>
+          </a:p>
+          <a:p/>
+          <a:p>
+            <a:r>
+              <a:t>В обычной работе мы тоже не можем постоянно перепроверять всё. Многое принимаем потому, что доверяем человеку, который нам это сообщает.</a:t>
+            </a:r>
+          </a:p>
+          <a:p/>
+          <a:p>
+            <a:r>
+              <a:t>В этом и парадокс: доверие становится особенно важным именно там, где заканчивается возможность всё проверить. Поэтому так важно бережно обращаться с чужими словами и их смыслом.</a:t>
             </a:r>
           </a:p>
         </p:txBody>
@@ -647,7 +688,25 @@
           <a:lstStyle/>
           <a:p>
             <a:r>
-              <a:t>Все показатели — демонстрационные. Реальные результаты ещё не добавлены. Анимация и музыка доступны в index.html и MP4.</a:t>
+              <a:t>В эксперименте «Руководитель и замена» мы решили показать доверие действием. Руководители на время передали сотрудникам часть своих функций и возможность самостоятельно принимать решения.</a:t>
+            </a:r>
+          </a:p>
+          <a:p/>
+          <a:p>
+            <a:r>
+              <a:t>Сказать «Я тебе доверяю» легко. Гораздо сложнее действительно дать другому человеку свободу действовать.</a:t>
+            </a:r>
+          </a:p>
+          <a:p/>
+          <a:p>
+            <a:r>
+              <a:t>Для нас именно в этом был смысл эксперимента: сделать доверие конкретным. Оно проявилось в переданных функциях и в возможности принимать решения, а не только в добрых словах.</a:t>
+            </a:r>
+          </a:p>
+          <a:p/>
+          <a:p>
+            <a:r>
+              <a:t>Наш вывод: настоящее доверие начинается там, где вместе с задачей мы готовы передать и ответственность. Свобода действий и ответственность здесь идут рядом.</a:t>
             </a:r>
           </a:p>
         </p:txBody>
@@ -717,7 +776,25 @@
           <a:lstStyle/>
           <a:p>
             <a:r>
-              <a:t>Все показатели — демонстрационные. Реальные результаты ещё не добавлены. Анимация и музыка доступны в index.html и MP4.</a:t>
+              <a:t>В следующем эксперименте для нас был важен не сам выбор — поверить или не поверить. Мы хотели увидеть границу между доверием и доверчивостью.</a:t>
+            </a:r>
+          </a:p>
+          <a:p/>
+          <a:p>
+            <a:r>
+              <a:t>Большинство коллег не приняли информацию безоговорочно и попытались оценить её достоверность. Для нас это важный результат.</a:t>
+            </a:r>
+          </a:p>
+          <a:p/>
+          <a:p>
+            <a:r>
+              <a:t>Доверие не отменяет критического мышления. Можно доверять человеку и при этом задавать вопросы, уточнять детали и оставлять место для сомнений.</a:t>
+            </a:r>
+          </a:p>
+          <a:p/>
+          <a:p>
+            <a:r>
+              <a:t>Зрелое доверие выдерживает такие вопросы. Ведь доверять — это не значит верить всему.</a:t>
             </a:r>
           </a:p>
         </p:txBody>
@@ -787,77 +864,49 @@
           <a:lstStyle/>
           <a:p>
             <a:r>
-              <a:t>Все показатели — демонстрационные. Реальные результаты ещё не добавлены. Анимация и музыка доступны в index.html и MP4.</a:t>
-            </a:r>
-          </a:p>
-        </p:txBody>
-      </p:sp>
-      <p:sp>
-        <p:nvSpPr>
-          <p:cNvPr id="4" name="Slide Number Placeholder 3"/>
-          <p:cNvSpPr>
-            <a:spLocks noGrp="1"/>
-          </p:cNvSpPr>
-          <p:nvPr>
-            <p:ph type="sldNum" idx="5" sz="quarter"/>
-          </p:nvPr>
-        </p:nvSpPr>
-        <p:spPr/>
-      </p:sp>
-    </p:spTree>
-  </p:cSld>
-  <p:clrMapOvr>
-    <a:masterClrMapping/>
-  </p:clrMapOvr>
-</p:notes>
-</file>
-
-<file path=ppt/notesSlides/notesSlide6.xml><?xml version="1.0" encoding="utf-8"?>
-<p:notes xmlns:a="http://schemas.openxmlformats.org/drawingml/2006/main" xmlns:p="http://schemas.openxmlformats.org/presentationml/2006/main" xmlns:r="http://schemas.openxmlformats.org/officeDocument/2006/relationships">
-  <p:cSld>
-    <p:spTree>
-      <p:nvGrpSpPr>
-        <p:cNvPr id="1" name=""/>
-        <p:cNvGrpSpPr/>
-        <p:nvPr/>
-      </p:nvGrpSpPr>
-      <p:grpSpPr>
-        <a:xfrm>
-          <a:off x="0" y="0"/>
-          <a:ext cx="0" cy="0"/>
-          <a:chOff x="0" y="0"/>
-          <a:chExt cx="0" cy="0"/>
-        </a:xfrm>
-      </p:grpSpPr>
-      <p:sp>
-        <p:nvSpPr>
-          <p:cNvPr id="2" name="Slide Image Placeholder 1"/>
-          <p:cNvSpPr>
-            <a:spLocks noGrp="1"/>
-          </p:cNvSpPr>
-          <p:nvPr>
-            <p:ph type="sldImg" idx="2"/>
-          </p:nvPr>
-        </p:nvSpPr>
-        <p:spPr/>
-      </p:sp>
-      <p:sp>
-        <p:nvSpPr>
-          <p:cNvPr id="3" name="Notes Placeholder 2"/>
-          <p:cNvSpPr>
-            <a:spLocks noGrp="1"/>
-          </p:cNvSpPr>
-          <p:nvPr>
-            <p:ph type="body" idx="3" sz="quarter"/>
-          </p:nvPr>
-        </p:nvSpPr>
-        <p:spPr/>
-        <p:txBody>
-          <a:bodyPr/>
-          <a:lstStyle/>
-          <a:p>
-            <a:r>
-              <a:t>Все показатели — демонстрационные. Реальные результаты ещё не добавлены. Анимация и музыка доступны в index.html и MP4.</a:t>
+              <a:t>Наши эксперименты показали разные проявления доверия. В дереве — участие. В вопросах и ответах — отношение к информации. В передаче функций — свободу и ответственность. В сомнениях — способность мыслить критически.</a:t>
+            </a:r>
+          </a:p>
+          <a:p/>
+          <a:p>
+            <a:r>
+              <a:t>Но основа у них одна: отношения между людьми.</a:t>
+            </a:r>
+          </a:p>
+          <a:p/>
+          <a:p>
+            <a:r>
+              <a:t>Доверие невозможно создать одним словом или одним поступком. Оно складывается постепенно — из открытости, участия, ответственности и ежедневных действий каждого из нас.</a:t>
+            </a:r>
+          </a:p>
+          <a:p/>
+          <a:p>
+            <a:r>
+              <a:t>[Пауза. Посмотреть на коллег.]</a:t>
+            </a:r>
+          </a:p>
+          <a:p/>
+          <a:p>
+            <a:r>
+              <a:t>Доверие трудно заслужить.</a:t>
+            </a:r>
+          </a:p>
+          <a:p/>
+          <a:p>
+            <a:r>
+              <a:t>Легко потерять.</a:t>
+            </a:r>
+          </a:p>
+          <a:p/>
+          <a:p>
+            <a:r>
+              <a:t>И очень важно сохранить.</a:t>
+            </a:r>
+          </a:p>
+          <a:p/>
+          <a:p>
+            <a:r>
+              <a:t>[Удержать финальный кадр три секунды.]</a:t>
             </a:r>
           </a:p>
         </p:txBody>
@@ -4034,48 +4083,6 @@
       <p:pic>
         <p:nvPicPr>
           <p:cNvPr id="2" name="Picture 1" descr="pdf_scene_05.png"/>
-          <p:cNvPicPr>
-            <a:picLocks noChangeAspect="1"/>
-          </p:cNvPicPr>
-          <p:nvPr/>
-        </p:nvPicPr>
-        <p:blipFill>
-          <a:blip r:embed="rId2"/>
-          <a:stretch>
-            <a:fillRect/>
-          </a:stretch>
-        </p:blipFill>
-        <p:spPr>
-          <a:xfrm>
-            <a:off x="0" y="0"/>
-            <a:ext cx="12191695" cy="8615510"/>
-          </a:xfrm>
-          <a:prstGeom prst="rect">
-            <a:avLst/>
-          </a:prstGeom>
-        </p:spPr>
-      </p:pic>
-    </p:spTree>
-  </p:cSld>
-  <p:clrMapOvr>
-    <a:masterClrMapping/>
-  </p:clrMapOvr>
-</p:sld>
-</file>
-
-<file path=ppt/slides/slide6.xml><?xml version="1.0" encoding="utf-8"?>
-<p:sld xmlns:a="http://schemas.openxmlformats.org/drawingml/2006/main" xmlns:p="http://schemas.openxmlformats.org/presentationml/2006/main" xmlns:r="http://schemas.openxmlformats.org/officeDocument/2006/relationships">
-  <p:cSld>
-    <p:spTree>
-      <p:nvGrpSpPr>
-        <p:cNvPr id="1" name=""/>
-        <p:cNvGrpSpPr/>
-        <p:nvPr/>
-      </p:nvGrpSpPr>
-      <p:grpSpPr/>
-      <p:pic>
-        <p:nvPicPr>
-          <p:cNvPr id="2" name="Picture 1" descr="pdf_scene_06.png"/>
           <p:cNvPicPr>
             <a:picLocks noChangeAspect="1"/>
           </p:cNvPicPr>

</xml_diff>